<commit_message>
feat(ensiu): sincroniza voz original y exporta MP4 final para YouTube
</commit_message>
<xml_diff>
--- a/outputs/ENSIU2026/PRESENTACION_ENSIU2026.pptx
+++ b/outputs/ENSIU2026/PRESENTACION_ENSIU2026.pptx
@@ -333,28 +333,23 @@
           <a:lstStyle/>
           <a:p>
             <a:r>
-              <a:rPr lang="es-CO"/>
-              <a:t>ESCENA 1: 0,00 a 6,30 segundos.</a:t>
-            </a:r>
-          </a:p>
-          <a:p>
-            <a:r>
-              <a:rPr lang="es-CO"/>
-              <a:t>Voz: ¿Y si una universidad pudiera estimar, con su historial, cómo le va a ir en el Saber Pro?</a:t>
-            </a:r>
-          </a:p>
-          <a:p>
-            <a:r>
-              <a:rPr lang="es-CO"/>
-              <a:t>La pista continua VOZ_ENSIU_60s.wav y CRONOMETRAJE.json fijan la sincronización del MP4.</a:t>
-            </a:r>
-          </a:p>
-          <a:p>
-            <a:r>
-              <a:rPr lang="es-CO"/>
-              <a:t>Fuentes: docs/ENSIU2026/Guion_Audiovisual_ENSIU2026.docx y Comunicacion_Ponencia_ENSIU2026.docx. Métricas: outputs/metrics/baseline_metrics.csv, metricas_lgbm_por_depto.csv y outputs/reports/decision_transformer.txt. Gráficos originales: outputs/figures/lgbm_predicho_vs_real.png y lgbm_error_por_departamento.png.</a:t>
-            </a:r>
-            <a:endParaRPr/>
+              <a:t>ESCENA 1: 0.000–3.600 s.</a:t>
+            </a:r>
+          </a:p>
+          <a:p>
+            <a:r>
+              <a:t>Narración definitiva: Grabación (14).m4a, 53,247771 s, sin cambios.</a:t>
+            </a:r>
+          </a:p>
+          <a:p>
+            <a:r>
+              <a:t>Referencia de sincronización: ¿Y si una universidad pudiera anticipar, con base en su propio historial,</a:t>
+            </a:r>
+          </a:p>
+          <a:p>
+            <a:r>
+              <a:t>Fuentes visuales y métricas: outputs/metrics/baseline_metrics.csv, metricas_lgbm_por_depto.csv, outputs/reports/decision_transformer.txt y gráficos originales de outputs/figures/.</a:t>
+            </a:r>
           </a:p>
         </p:txBody>
       </p:sp>
@@ -430,28 +425,23 @@
           <a:lstStyle/>
           <a:p>
             <a:r>
-              <a:rPr lang="es-CO"/>
-              <a:t>ESCENA 2: 6,30 a 10,00 segundos.</a:t>
-            </a:r>
-          </a:p>
-          <a:p>
-            <a:r>
-              <a:rPr lang="es-CO"/>
-              <a:t>Voz: Hoy, con Inteligencia Artificial, ya es posible.</a:t>
-            </a:r>
-          </a:p>
-          <a:p>
-            <a:r>
-              <a:rPr lang="es-CO"/>
-              <a:t>La pista continua VOZ_ENSIU_60s.wav y CRONOMETRAJE.json fijan la sincronización del MP4.</a:t>
-            </a:r>
-          </a:p>
-          <a:p>
-            <a:r>
-              <a:rPr lang="es-CO"/>
-              <a:t>Fuentes: docs/ENSIU2026/Guion_Audiovisual_ENSIU2026.docx y Comunicacion_Ponencia_ENSIU2026.docx. Métricas: outputs/metrics/baseline_metrics.csv, metricas_lgbm_por_depto.csv y outputs/reports/decision_transformer.txt. Gráficos originales: outputs/figures/lgbm_predicho_vs_real.png y lgbm_error_por_departamento.png.</a:t>
-            </a:r>
-            <a:endParaRPr/>
+              <a:t>ESCENA 2: 3.600–6.500 s.</a:t>
+            </a:r>
+          </a:p>
+          <a:p>
+            <a:r>
+              <a:t>Narración definitiva: Grabación (14).m4a, 53,247771 s, sin cambios.</a:t>
+            </a:r>
+          </a:p>
+          <a:p>
+            <a:r>
+              <a:t>Referencia de sincronización: cómo será el desempeño de sus programas en Saber Pro?</a:t>
+            </a:r>
+          </a:p>
+          <a:p>
+            <a:r>
+              <a:t>Fuentes visuales y métricas: outputs/metrics/baseline_metrics.csv, metricas_lgbm_por_depto.csv, outputs/reports/decision_transformer.txt y gráficos originales de outputs/figures/.</a:t>
+            </a:r>
           </a:p>
         </p:txBody>
       </p:sp>
@@ -527,28 +517,23 @@
           <a:lstStyle/>
           <a:p>
             <a:r>
-              <a:rPr lang="es-CO"/>
-              <a:t>ESCENA 3: 10,00 a 17,00 segundos.</a:t>
-            </a:r>
-          </a:p>
-          <a:p>
-            <a:r>
-              <a:rPr lang="es-CO"/>
-              <a:t>Voz: Analizamos cinco años de datos abiertos del ICFES, más de ciento veintisiete mil registros,</a:t>
-            </a:r>
-          </a:p>
-          <a:p>
-            <a:r>
-              <a:rPr lang="es-CO"/>
-              <a:t>La pista continua VOZ_ENSIU_60s.wav y CRONOMETRAJE.json fijan la sincronización del MP4.</a:t>
-            </a:r>
-          </a:p>
-          <a:p>
-            <a:r>
-              <a:rPr lang="es-CO"/>
-              <a:t>Fuentes: docs/ENSIU2026/Guion_Audiovisual_ENSIU2026.docx y Comunicacion_Ponencia_ENSIU2026.docx. Métricas: outputs/metrics/baseline_metrics.csv, metricas_lgbm_por_depto.csv y outputs/reports/decision_transformer.txt. Gráficos originales: outputs/figures/lgbm_predicho_vs_real.png y lgbm_error_por_departamento.png.</a:t>
-            </a:r>
-            <a:endParaRPr/>
+              <a:t>ESCENA 3: 6.500–17.000 s.</a:t>
+            </a:r>
+          </a:p>
+          <a:p>
+            <a:r>
+              <a:t>Narración definitiva: Grabación (14).m4a, 53,247771 s, sin cambios.</a:t>
+            </a:r>
+          </a:p>
+          <a:p>
+            <a:r>
+              <a:t>Referencia de sincronización: En este trabajo analizamos 127.716 observaciones abiertas del ICFES entre 2020 y 2024, y entrenamos varios modelos para estimar el resultado del año siguiente.</a:t>
+            </a:r>
+          </a:p>
+          <a:p>
+            <a:r>
+              <a:t>Fuentes visuales y métricas: outputs/metrics/baseline_metrics.csv, metricas_lgbm_por_depto.csv, outputs/reports/decision_transformer.txt y gráficos originales de outputs/figures/.</a:t>
+            </a:r>
           </a:p>
         </p:txBody>
       </p:sp>
@@ -624,28 +609,23 @@
           <a:lstStyle/>
           <a:p>
             <a:r>
-              <a:rPr lang="es-CO"/>
-              <a:t>ESCENA 4: 17,00 a 26,00 segundos.</a:t>
-            </a:r>
-          </a:p>
-          <a:p>
-            <a:r>
-              <a:rPr lang="es-CO"/>
-              <a:t>Voz: y construimos un modelo con un error cuadrático medio de nueve coma treinta y tres puntos.</a:t>
-            </a:r>
-          </a:p>
-          <a:p>
-            <a:r>
-              <a:rPr lang="es-CO"/>
-              <a:t>La pista continua VOZ_ENSIU_60s.wav y CRONOMETRAJE.json fijan la sincronización del MP4.</a:t>
-            </a:r>
-          </a:p>
-          <a:p>
-            <a:r>
-              <a:rPr lang="es-CO"/>
-              <a:t>Fuentes: docs/ENSIU2026/Guion_Audiovisual_ENSIU2026.docx y Comunicacion_Ponencia_ENSIU2026.docx. Métricas: outputs/metrics/baseline_metrics.csv, metricas_lgbm_por_depto.csv y outputs/reports/decision_transformer.txt. Gráficos originales: outputs/figures/lgbm_predicho_vs_real.png y lgbm_error_por_departamento.png.</a:t>
-            </a:r>
-            <a:endParaRPr/>
+              <a:t>ESCENA 4: 17.000–32.200 s.</a:t>
+            </a:r>
+          </a:p>
+          <a:p>
+            <a:r>
+              <a:t>Narración definitiva: Grabación (14).m4a, 53,247771 s, sin cambios.</a:t>
+            </a:r>
+          </a:p>
+          <a:p>
+            <a:r>
+              <a:t>Referencia de sincronización: LightGBM obtuvo el mejor desempeño, con un R al cuadrado o coeficiente de determinación de 0,706, y un error cuadrático medio de 9,33 puntos, superando a Ridge, Lasso y Transformer.</a:t>
+            </a:r>
+          </a:p>
+          <a:p>
+            <a:r>
+              <a:t>Fuentes visuales y métricas: outputs/metrics/baseline_metrics.csv, metricas_lgbm_por_depto.csv, outputs/reports/decision_transformer.txt y gráficos originales de outputs/figures/.</a:t>
+            </a:r>
           </a:p>
         </p:txBody>
       </p:sp>
@@ -721,28 +701,23 @@
           <a:lstStyle/>
           <a:p>
             <a:r>
-              <a:rPr lang="es-CO"/>
-              <a:t>ESCENA 5: 26,00 a 40,00 segundos.</a:t>
-            </a:r>
-          </a:p>
-          <a:p>
-            <a:r>
-              <a:rPr lang="es-CO"/>
-              <a:t>Voz: Pero encontramos algo más importante: los mayores errores están en Sucre, Chocó y Putumayo. Este hallazgo orienta dónde reforzar los datos y el acompañamiento.</a:t>
-            </a:r>
-          </a:p>
-          <a:p>
-            <a:r>
-              <a:rPr lang="es-CO"/>
-              <a:t>La pista continua VOZ_ENSIU_60s.wav y CRONOMETRAJE.json fijan la sincronización del MP4.</a:t>
-            </a:r>
-          </a:p>
-          <a:p>
-            <a:r>
-              <a:rPr lang="es-CO"/>
-              <a:t>Fuentes: docs/ENSIU2026/Guion_Audiovisual_ENSIU2026.docx y Comunicacion_Ponencia_ENSIU2026.docx. Métricas: outputs/metrics/baseline_metrics.csv, metricas_lgbm_por_depto.csv y outputs/reports/decision_transformer.txt. Gráficos originales: outputs/figures/lgbm_predicho_vs_real.png y lgbm_error_por_departamento.png.</a:t>
-            </a:r>
-            <a:endParaRPr/>
+              <a:t>ESCENA 5: 32.200–40.100 s.</a:t>
+            </a:r>
+          </a:p>
+          <a:p>
+            <a:r>
+              <a:t>Narración definitiva: Grabación (14).m4a, 53,247771 s, sin cambios.</a:t>
+            </a:r>
+          </a:p>
+          <a:p>
+            <a:r>
+              <a:t>Referencia de sincronización: Además, encontramos que el error no se distribuye igual en todo el país. Sucre, Chocó y Putumayo presentan los mayores valores.</a:t>
+            </a:r>
+          </a:p>
+          <a:p>
+            <a:r>
+              <a:t>Fuentes visuales y métricas: outputs/metrics/baseline_metrics.csv, metricas_lgbm_por_depto.csv, outputs/reports/decision_transformer.txt y gráficos originales de outputs/figures/.</a:t>
+            </a:r>
           </a:p>
         </p:txBody>
       </p:sp>
@@ -818,28 +793,23 @@
           <a:lstStyle/>
           <a:p>
             <a:r>
-              <a:rPr lang="es-CO"/>
-              <a:t>ESCENA 6: 40,00 a 49,30 segundos.</a:t>
-            </a:r>
-          </a:p>
-          <a:p>
-            <a:r>
-              <a:rPr lang="es-CO"/>
-              <a:t>Voz: Esto no es solo un modelo: es una alerta temprana para que las universidades actúen a tiempo, justo donde más se necesita.</a:t>
-            </a:r>
-          </a:p>
-          <a:p>
-            <a:r>
-              <a:rPr lang="es-CO"/>
-              <a:t>La pista continua VOZ_ENSIU_60s.wav y CRONOMETRAJE.json fijan la sincronización del MP4.</a:t>
-            </a:r>
-          </a:p>
-          <a:p>
-            <a:r>
-              <a:rPr lang="es-CO"/>
-              <a:t>Fuentes: docs/ENSIU2026/Guion_Audiovisual_ENSIU2026.docx y Comunicacion_Ponencia_ENSIU2026.docx. Métricas: outputs/metrics/baseline_metrics.csv, metricas_lgbm_por_depto.csv y outputs/reports/decision_transformer.txt. Gráficos originales: outputs/figures/lgbm_predicho_vs_real.png y lgbm_error_por_departamento.png.</a:t>
-            </a:r>
-            <a:endParaRPr/>
+              <a:t>ESCENA 6: 40.100–50.267 s.</a:t>
+            </a:r>
+          </a:p>
+          <a:p>
+            <a:r>
+              <a:t>Narración definitiva: Grabación (14).m4a, 53,247771 s, sin cambios.</a:t>
+            </a:r>
+          </a:p>
+          <a:p>
+            <a:r>
+              <a:t>Referencia de sincronización: Esto convierte en la predicción en algo más que una métrica. Puede funcionar como una alerta temprana para orientar acompañamiento, fortalecer datos y apoyar decisiones institucionales</a:t>
+            </a:r>
+          </a:p>
+          <a:p>
+            <a:r>
+              <a:t>Fuentes visuales y métricas: outputs/metrics/baseline_metrics.csv, metricas_lgbm_por_depto.csv, outputs/reports/decision_transformer.txt y gráficos originales de outputs/figures/.</a:t>
+            </a:r>
           </a:p>
         </p:txBody>
       </p:sp>
@@ -915,28 +885,23 @@
           <a:lstStyle/>
           <a:p>
             <a:r>
-              <a:rPr lang="es-CO"/>
-              <a:t>ESCENA 7: 49,30 a 53,20 segundos.</a:t>
-            </a:r>
-          </a:p>
-          <a:p>
-            <a:r>
-              <a:rPr lang="es-CO"/>
-              <a:t>Voz: Inteligencia Artificial al servicio de la equidad educativa.</a:t>
-            </a:r>
-          </a:p>
-          <a:p>
-            <a:r>
-              <a:rPr lang="es-CO"/>
-              <a:t>La pista continua VOZ_ENSIU_60s.wav y CRONOMETRAJE.json fijan la sincronización del MP4.</a:t>
-            </a:r>
-          </a:p>
-          <a:p>
-            <a:r>
-              <a:rPr lang="es-CO"/>
-              <a:t>Fuentes: docs/ENSIU2026/Guion_Audiovisual_ENSIU2026.docx y Comunicacion_Ponencia_ENSIU2026.docx. Métricas: outputs/metrics/baseline_metrics.csv, metricas_lgbm_por_depto.csv y outputs/reports/decision_transformer.txt. Gráficos originales: outputs/figures/lgbm_predicho_vs_real.png y lgbm_error_por_departamento.png.</a:t>
-            </a:r>
-            <a:endParaRPr/>
+              <a:t>ESCENA 7: 50.267–53.267 s.</a:t>
+            </a:r>
+          </a:p>
+          <a:p>
+            <a:r>
+              <a:t>Narración definitiva: Grabación (14).m4a, 53,247771 s, sin cambios.</a:t>
+            </a:r>
+          </a:p>
+          <a:p>
+            <a:r>
+              <a:t>Referencia de sincronización: con enfoque de equidad educativa.</a:t>
+            </a:r>
+          </a:p>
+          <a:p>
+            <a:r>
+              <a:t>Fuentes visuales y métricas: outputs/metrics/baseline_metrics.csv, metricas_lgbm_por_depto.csv, outputs/reports/decision_transformer.txt y gráficos originales de outputs/figures/.</a:t>
+            </a:r>
           </a:p>
         </p:txBody>
       </p:sp>
@@ -1012,28 +977,23 @@
           <a:lstStyle/>
           <a:p>
             <a:r>
-              <a:rPr lang="es-CO"/>
-              <a:t>ESCENA 8: 53,20 a 60,00 segundos.</a:t>
-            </a:r>
-          </a:p>
-          <a:p>
-            <a:r>
-              <a:rPr lang="es-CO"/>
-              <a:t>Voz: Un trabajo de UNIMINUTO para las Misiones de Conocimiento. ENSIU dos mil veintiséis.</a:t>
-            </a:r>
-          </a:p>
-          <a:p>
-            <a:r>
-              <a:rPr lang="es-CO"/>
-              <a:t>La pista continua VOZ_ENSIU_60s.wav y CRONOMETRAJE.json fijan la sincronización del MP4.</a:t>
-            </a:r>
-          </a:p>
-          <a:p>
-            <a:r>
-              <a:rPr lang="es-CO"/>
-              <a:t>Fuentes: docs/ENSIU2026/Guion_Audiovisual_ENSIU2026.docx y Comunicacion_Ponencia_ENSIU2026.docx. Métricas: outputs/metrics/baseline_metrics.csv, metricas_lgbm_por_depto.csv y outputs/reports/decision_transformer.txt. Gráficos originales: outputs/figures/lgbm_predicho_vs_real.png y lgbm_error_por_departamento.png.</a:t>
-            </a:r>
-            <a:endParaRPr/>
+              <a:t>ESCENA 8: 53.267–60.000 s.</a:t>
+            </a:r>
+          </a:p>
+          <a:p>
+            <a:r>
+              <a:t>Narración definitiva: Grabación (14).m4a, 53,247771 s, sin cambios.</a:t>
+            </a:r>
+          </a:p>
+          <a:p>
+            <a:r>
+              <a:t>Cierre visual sin audio: ENSIU 2026, UNIMINUTO, autores y Misión 4.</a:t>
+            </a:r>
+          </a:p>
+          <a:p>
+            <a:r>
+              <a:t>Fuentes visuales y métricas: outputs/metrics/baseline_metrics.csv, metricas_lgbm_por_depto.csv, outputs/reports/decision_transformer.txt y gráficos originales de outputs/figures/.</a:t>
+            </a:r>
           </a:p>
         </p:txBody>
       </p:sp>
@@ -1628,10 +1588,10 @@
   </p:clrMapOvr>
   <mc:AlternateContent xmlns:mc="http://schemas.openxmlformats.org/markup-compatibility/2006">
     <mc:Choice xmlns:p14="http://schemas.microsoft.com/office/powerpoint/2010/main" Requires="p14">
-      <p:transition spd="slow" p14:dur="2000" advClick="0" advTm="6300"/>
+      <p:transition spd="slow" p14:dur="2000" advClick="0" advTm="3600"/>
     </mc:Choice>
     <mc:Fallback>
-      <p:transition spd="slow" advClick="0" advTm="6300"/>
+      <p:transition spd="slow" advClick="0" advTm="3600"/>
     </mc:Fallback>
   </mc:AlternateContent>
 </p:sld>
@@ -1868,10 +1828,10 @@
   </p:clrMapOvr>
   <mc:AlternateContent xmlns:mc="http://schemas.openxmlformats.org/markup-compatibility/2006">
     <mc:Choice xmlns:p14="http://schemas.microsoft.com/office/powerpoint/2010/main" Requires="p14">
-      <p:transition spd="slow" p14:dur="2000" advClick="0" advTm="3700"/>
+      <p:transition spd="slow" p14:dur="2000" advClick="0" advTm="2900"/>
     </mc:Choice>
     <mc:Fallback>
-      <p:transition spd="slow" advClick="0" advTm="3700"/>
+      <p:transition spd="slow" advClick="0" advTm="2900"/>
     </mc:Fallback>
   </mc:AlternateContent>
 </p:sld>
@@ -2279,10 +2239,10 @@
   </p:clrMapOvr>
   <mc:AlternateContent xmlns:mc="http://schemas.openxmlformats.org/markup-compatibility/2006">
     <mc:Choice xmlns:p14="http://schemas.microsoft.com/office/powerpoint/2010/main" Requires="p14">
-      <p:transition spd="slow" p14:dur="2000" advClick="0" advTm="7000"/>
+      <p:transition spd="slow" p14:dur="2000" advClick="0" advTm="10500"/>
     </mc:Choice>
     <mc:Fallback>
-      <p:transition spd="slow" advClick="0" advTm="7000"/>
+      <p:transition spd="slow" advClick="0" advTm="10500"/>
     </mc:Fallback>
   </mc:AlternateContent>
 </p:sld>
@@ -2998,10 +2958,10 @@
   </p:clrMapOvr>
   <mc:AlternateContent xmlns:mc="http://schemas.openxmlformats.org/markup-compatibility/2006">
     <mc:Choice xmlns:p14="http://schemas.microsoft.com/office/powerpoint/2010/main" Requires="p14">
-      <p:transition spd="slow" p14:dur="2000" advClick="0" advTm="9000"/>
+      <p:transition spd="slow" p14:dur="2000" advClick="0" advTm="15200"/>
     </mc:Choice>
     <mc:Fallback>
-      <p:transition spd="slow" advClick="0" advTm="9000"/>
+      <p:transition spd="slow" advClick="0" advTm="15200"/>
     </mc:Fallback>
   </mc:AlternateContent>
 </p:sld>
@@ -3750,10 +3710,10 @@
   </p:clrMapOvr>
   <mc:AlternateContent xmlns:mc="http://schemas.openxmlformats.org/markup-compatibility/2006">
     <mc:Choice xmlns:p14="http://schemas.microsoft.com/office/powerpoint/2010/main" Requires="p14">
-      <p:transition spd="slow" p14:dur="2000" advClick="0" advTm="14000"/>
+      <p:transition spd="slow" p14:dur="2000" advClick="0" advTm="7900"/>
     </mc:Choice>
     <mc:Fallback>
-      <p:transition spd="slow" advClick="0" advTm="14000"/>
+      <p:transition spd="slow" advClick="0" advTm="7900"/>
     </mc:Fallback>
   </mc:AlternateContent>
 </p:sld>
@@ -3990,10 +3950,10 @@
   </p:clrMapOvr>
   <mc:AlternateContent xmlns:mc="http://schemas.openxmlformats.org/markup-compatibility/2006">
     <mc:Choice xmlns:p14="http://schemas.microsoft.com/office/powerpoint/2010/main" Requires="p14">
-      <p:transition spd="slow" p14:dur="2000" advClick="0" advTm="9300"/>
+      <p:transition spd="slow" p14:dur="2000" advClick="0" advTm="10167"/>
     </mc:Choice>
     <mc:Fallback>
-      <p:transition spd="slow" advClick="0" advTm="9300"/>
+      <p:transition spd="slow" advClick="0" advTm="10167"/>
     </mc:Fallback>
   </mc:AlternateContent>
 </p:sld>
@@ -4230,10 +4190,10 @@
   </p:clrMapOvr>
   <mc:AlternateContent xmlns:mc="http://schemas.openxmlformats.org/markup-compatibility/2006">
     <mc:Choice xmlns:p14="http://schemas.microsoft.com/office/powerpoint/2010/main" Requires="p14">
-      <p:transition spd="slow" p14:dur="2000" advClick="0" advTm="3900"/>
+      <p:transition spd="slow" p14:dur="2000" advClick="0" advTm="3000"/>
     </mc:Choice>
     <mc:Fallback>
-      <p:transition spd="slow" advClick="0" advTm="3900"/>
+      <p:transition spd="slow" advClick="0" advTm="3000"/>
     </mc:Fallback>
   </mc:AlternateContent>
 </p:sld>
@@ -4584,10 +4544,10 @@
   </p:clrMapOvr>
   <mc:AlternateContent xmlns:mc="http://schemas.openxmlformats.org/markup-compatibility/2006">
     <mc:Choice xmlns:p14="http://schemas.microsoft.com/office/powerpoint/2010/main" Requires="p14">
-      <p:transition spd="slow" p14:dur="2000" advClick="0" advTm="6800"/>
+      <p:transition spd="slow" p14:dur="2000" advClick="0" advTm="6733"/>
     </mc:Choice>
     <mc:Fallback>
-      <p:transition spd="slow" advClick="0" advTm="6800"/>
+      <p:transition spd="slow" advClick="0" advTm="6733"/>
     </mc:Fallback>
   </mc:AlternateContent>
 </p:sld>

</xml_diff>